<commit_message>
Remove hardcoded student name, roll number, and Java CIE-2 inspector from UI and slides
</commit_message>
<xml_diff>
--- a/Online_Quiz_Management_System_4Slides.pptx
+++ b/Online_Quiz_Management_System_4Slides.pptx
@@ -6246,7 +6246,7 @@
                   <a:srgbClr val="334155"/>
                 </a:solidFill>
               </a:rPr>
-              <a:t>5-tab navigation: Quizzes, Active Quiz, Score History, Faculty, and Concept Defense.</a:t>
+              <a:t>5-tab navigation: Quizzes, Active Quiz, Score History, Faculty, and Viva Guide.</a:t>
             </a:r>
           </a:p>
           <a:p>
@@ -6264,7 +6264,7 @@
                   <a:srgbClr val="0F172A"/>
                 </a:solidFill>
               </a:rPr>
-              <a:t>• Student Pill: </a:t>
+              <a:t>• Portal Branding: </a:t>
             </a:r>
             <a:r>
               <a:rPr>
@@ -6272,7 +6272,7 @@
                   <a:srgbClr val="334155"/>
                 </a:solidFill>
               </a:rPr>
-              <a:t>Displays active logged-in student name, roll number, and division in header.</a:t>
+              <a:t>Clean, modern institutional branding with persistent top-level navigation.</a:t>
             </a:r>
           </a:p>
         </p:txBody>
@@ -6938,7 +6938,7 @@
               </a:defRPr>
             </a:pPr>
             <a:r>
-              <a:t>FACULTY &amp; CONCEPT DEFENSE</a:t>
+              <a:t>FACULTY &amp; AUTHORING PORTAL</a:t>
             </a:r>
           </a:p>
           <a:p>
@@ -6954,7 +6954,7 @@
               </a:defRPr>
             </a:pPr>
             <a:r>
-              <a:t>6. Faculty Management &amp; CIE-2 Inspector</a:t>
+              <a:t>6. Faculty Management &amp; Question Authoring</a:t>
             </a:r>
           </a:p>
           <a:p>
@@ -6998,7 +6998,7 @@
                   <a:srgbClr val="0F172A"/>
                 </a:solidFill>
               </a:rPr>
-              <a:t>• Live Viva Inspector: </a:t>
+              <a:t>• Dynamic Schema Control: </a:t>
             </a:r>
             <a:r>
               <a:rPr>
@@ -7006,7 +7006,7 @@
                   <a:srgbClr val="334155"/>
                 </a:solidFill>
               </a:rPr>
-              <a:t>Dedicated CIE-2 concept defense tab explaining OOP, interfaces, and exceptions.</a:t>
+              <a:t>Add multiple choice, true/false, or numeric questions with custom marking.</a:t>
             </a:r>
           </a:p>
           <a:p>
@@ -7024,7 +7024,7 @@
                   <a:srgbClr val="0F172A"/>
                 </a:solidFill>
               </a:rPr>
-              <a:t>• 1-Click Concept Test: </a:t>
+              <a:t>• Submissions Audit Matrix: </a:t>
             </a:r>
             <a:r>
               <a:rPr>
@@ -7032,7 +7032,7 @@
                   <a:srgbClr val="334155"/>
                 </a:solidFill>
               </a:rPr>
-              <a:t>Button to execute the automated concept verification matrix live in browser.</a:t>
+              <a:t>Comprehensive gradebook table tracking attempts, grading policies, and results.</a:t>
             </a:r>
           </a:p>
         </p:txBody>

</xml_diff>

<commit_message>
Update PPT slides with explicit Unit III & Unit IV syllabus topic division for each teammate
</commit_message>
<xml_diff>
--- a/Online_Quiz_Management_System_4Slides.pptx
+++ b/Online_Quiz_Management_System_4Slides.pptx
@@ -3477,7 +3477,7 @@
                 </a:solidFill>
                 <a:latin typeface="Arial"/>
               </a:rPr>
-              <a:t>System Architect &amp; Integration Lead</a:t>
+              <a:t>System Architect &amp; Model Lead</a:t>
             </a:r>
           </a:p>
           <a:p>
@@ -3493,7 +3493,7 @@
                 </a:solidFill>
                 <a:latin typeface="Arial"/>
               </a:rPr>
-              <a:t>• Interfaces: </a:t>
+              <a:t>• Unit III: </a:t>
             </a:r>
             <a:r>
               <a:rPr sz="850">
@@ -3502,7 +3502,7 @@
                 </a:solidFill>
                 <a:latin typeface="Arial"/>
               </a:rPr>
-              <a:t>QuizOperations &amp; QuizEvaluator contracts</a:t>
+              <a:t>Abstract Classes (Question &amp; User)</a:t>
             </a:r>
           </a:p>
           <a:p>
@@ -3518,7 +3518,7 @@
                 </a:solidFill>
                 <a:latin typeface="Arial"/>
               </a:rPr>
-              <a:t>• Patterns: </a:t>
+              <a:t>• Unit IV: </a:t>
             </a:r>
             <a:r>
               <a:rPr sz="850">
@@ -3527,7 +3527,7 @@
                 </a:solidFill>
                 <a:latin typeface="Arial"/>
               </a:rPr>
-              <a:t>Strategy Pattern &amp; Polymorphic binding</a:t>
+              <a:t>Types of Error &amp; Constructor Guards</a:t>
             </a:r>
           </a:p>
           <a:p>
@@ -3543,7 +3543,7 @@
                 </a:solidFill>
                 <a:latin typeface="Arial"/>
               </a:rPr>
-              <a:t>• Coordination: </a:t>
+              <a:t>• Viva Focus: </a:t>
             </a:r>
             <a:r>
               <a:rPr sz="850">
@@ -3552,7 +3552,7 @@
                 </a:solidFill>
                 <a:latin typeface="Arial"/>
               </a:rPr>
-              <a:t>Submission alignment &amp; Rubric compliance</a:t>
+              <a:t>IS-A Encapsulation &amp; Abstract Methods</a:t>
             </a:r>
           </a:p>
         </p:txBody>
@@ -3664,7 +3664,7 @@
                 </a:solidFill>
                 <a:latin typeface="Arial"/>
               </a:rPr>
-              <a:t>OOP &amp; Custom Exceptions Lead</a:t>
+              <a:t>Polymorphic Questions Lead</a:t>
             </a:r>
           </a:p>
           <a:p>
@@ -3680,7 +3680,7 @@
                 </a:solidFill>
                 <a:latin typeface="Arial"/>
               </a:rPr>
-              <a:t>• Abstract Classes: </a:t>
+              <a:t>• Unit III: </a:t>
             </a:r>
             <a:r>
               <a:rPr sz="850">
@@ -3689,7 +3689,7 @@
                 </a:solidFill>
                 <a:latin typeface="Arial"/>
               </a:rPr>
-              <a:t>Question &amp; User base hierarchies</a:t>
+              <a:t>Overriding &amp; Dynamic Binding (vtable)</a:t>
             </a:r>
           </a:p>
           <a:p>
@@ -3705,7 +3705,7 @@
                 </a:solidFill>
                 <a:latin typeface="Arial"/>
               </a:rPr>
-              <a:t>• Exception Tree: </a:t>
+              <a:t>• Unit IV: </a:t>
             </a:r>
             <a:r>
               <a:rPr sz="850">
@@ -3714,7 +3714,7 @@
                 </a:solidFill>
                 <a:latin typeface="Arial"/>
               </a:rPr>
-              <a:t>5-tier checked QuizException hierarchy</a:t>
+              <a:t>Exception Interception (InvalidOption)</a:t>
             </a:r>
           </a:p>
           <a:p>
@@ -3730,7 +3730,7 @@
                 </a:solidFill>
                 <a:latin typeface="Arial"/>
               </a:rPr>
-              <a:t>• Archetypes: </a:t>
+              <a:t>• Viva Focus: </a:t>
             </a:r>
             <a:r>
               <a:rPr sz="850">
@@ -3739,7 +3739,7 @@
                 </a:solidFill>
                 <a:latin typeface="Arial"/>
               </a:rPr>
-              <a:t>MCQ, True/False &amp; Numeric questions</a:t>
+              <a:t>MCQ/TF/Num Dispatch &amp; Overloading</a:t>
             </a:r>
           </a:p>
         </p:txBody>
@@ -3797,7 +3797,7 @@
               </a:defRPr>
             </a:pPr>
             <a:r>
-              <a:t>WEB DEVELOPER</a:t>
+              <a:t>STRATEGY ENGINEER</a:t>
             </a:r>
           </a:p>
           <a:p>
@@ -3851,7 +3851,7 @@
                 </a:solidFill>
                 <a:latin typeface="Arial"/>
               </a:rPr>
-              <a:t>Full-Stack Web &amp; REST Engineer</a:t>
+              <a:t>Service &amp; Design Pattern Lead</a:t>
             </a:r>
           </a:p>
           <a:p>
@@ -3867,7 +3867,7 @@
                 </a:solidFill>
                 <a:latin typeface="Arial"/>
               </a:rPr>
-              <a:t>• Server: </a:t>
+              <a:t>• Unit III: </a:t>
             </a:r>
             <a:r>
               <a:rPr sz="850">
@@ -3876,7 +3876,7 @@
                 </a:solidFill>
                 <a:latin typeface="Arial"/>
               </a:rPr>
-              <a:t>Embedded Java HttpServer on port 8080</a:t>
+              <a:t>Interfaces &amp; Strategy Pattern (Grading)</a:t>
             </a:r>
           </a:p>
           <a:p>
@@ -3892,7 +3892,7 @@
                 </a:solidFill>
                 <a:latin typeface="Arial"/>
               </a:rPr>
-              <a:t>• Client UI: </a:t>
+              <a:t>• Unit IV: </a:t>
             </a:r>
             <a:r>
               <a:rPr sz="850">
@@ -3901,7 +3901,7 @@
                 </a:solidFill>
                 <a:latin typeface="Arial"/>
               </a:rPr>
-              <a:t>Responsive Glassmorphism Web App</a:t>
+              <a:t>Exception Propagation &amp; 'throws' Signatures</a:t>
             </a:r>
           </a:p>
           <a:p>
@@ -3917,7 +3917,7 @@
                 </a:solidFill>
                 <a:latin typeface="Arial"/>
               </a:rPr>
-              <a:t>• Timer &amp; JSON: </a:t>
+              <a:t>• Viva Focus: </a:t>
             </a:r>
             <a:r>
               <a:rPr sz="850">
@@ -3926,7 +3926,7 @@
                 </a:solidFill>
                 <a:latin typeface="Arial"/>
               </a:rPr>
-              <a:t>Live 10-min countdown &amp; REST APIs</a:t>
+              <a:t>QuizEvaluator Decoupling &amp; Open/Closed</a:t>
             </a:r>
           </a:p>
         </p:txBody>
@@ -4038,7 +4038,7 @@
                 </a:solidFill>
                 <a:latin typeface="Arial"/>
               </a:rPr>
-              <a:t>Quality Assurance &amp; Evaluation Lead</a:t>
+              <a:t>Quality Assurance &amp; Exceptions Lead</a:t>
             </a:r>
           </a:p>
           <a:p>
@@ -4054,7 +4054,7 @@
                 </a:solidFill>
                 <a:latin typeface="Arial"/>
               </a:rPr>
-              <a:t>• Test Suite: </a:t>
+              <a:t>• Unit III: </a:t>
             </a:r>
             <a:r>
               <a:rPr sz="850">
@@ -4063,7 +4063,7 @@
                 </a:solidFill>
                 <a:latin typeface="Arial"/>
               </a:rPr>
-              <a:t>Automated CIE-2 viva demonstration harness</a:t>
+              <a:t>QuizManager Operations Implementation</a:t>
             </a:r>
           </a:p>
           <a:p>
@@ -4079,7 +4079,7 @@
                 </a:solidFill>
                 <a:latin typeface="Arial"/>
               </a:rPr>
-              <a:t>• Validation: </a:t>
+              <a:t>• Unit IV: </a:t>
             </a:r>
             <a:r>
               <a:rPr sz="850">
@@ -4088,7 +4088,7 @@
                 </a:solidFill>
                 <a:latin typeface="Arial"/>
               </a:rPr>
-              <a:t>Standard vs 25% Negative Marking verification</a:t>
+              <a:t>5-Tier Checked Exceptions &amp; try-finally</a:t>
             </a:r>
           </a:p>
           <a:p>
@@ -4104,7 +4104,7 @@
                 </a:solidFill>
                 <a:latin typeface="Arial"/>
               </a:rPr>
-              <a:t>• Defensive Code: </a:t>
+              <a:t>• Viva Focus: </a:t>
             </a:r>
             <a:r>
               <a:rPr sz="850">
@@ -4113,7 +4113,7 @@
                 </a:solidFill>
                 <a:latin typeface="Arial"/>
               </a:rPr>
-              <a:t>Zero-crash input interceptors &amp; recovery</a:t>
+              <a:t>Domain Exception Tree &amp; Crash Prevention</a:t>
             </a:r>
           </a:p>
         </p:txBody>

</xml_diff>

<commit_message>
Add official AIT Pune college logo and detailed Unit 3 & 4 topic deep-dive slides for each teammate
</commit_message>
<xml_diff>
--- a/Online_Quiz_Management_System_4Slides.pptx
+++ b/Online_Quiz_Management_System_4Slides.pptx
@@ -3228,7 +3228,7 @@
       </p:sp>
       <p:pic>
         <p:nvPicPr>
-          <p:cNvPr id="5" name="Picture 4" descr="ait_badge.jpg"/>
+          <p:cNvPr id="5" name="Picture 4" descr="ait_official_badge.png"/>
           <p:cNvPicPr>
             <a:picLocks noChangeAspect="1"/>
           </p:cNvPicPr>
@@ -3423,7 +3423,7 @@
               </a:defRPr>
             </a:pPr>
             <a:r>
-              <a:t>GROUP LEADER</a:t>
+              <a:t>GROUP LEADER &amp; ARCHITECT</a:t>
             </a:r>
           </a:p>
           <a:p>
@@ -3468,7 +3468,7 @@
                 </a:solidFill>
                 <a:latin typeface="Arial"/>
               </a:rPr>
-              <a:t>• Role: </a:t>
+              <a:t>• Unit III: </a:t>
             </a:r>
             <a:r>
               <a:rPr sz="850">
@@ -3477,7 +3477,7 @@
                 </a:solidFill>
                 <a:latin typeface="Arial"/>
               </a:rPr>
-              <a:t>System Architect &amp; Model Lead</a:t>
+              <a:t>Abstract Classes (Question &amp; User)</a:t>
             </a:r>
           </a:p>
           <a:p>
@@ -3493,7 +3493,7 @@
                 </a:solidFill>
                 <a:latin typeface="Arial"/>
               </a:rPr>
-              <a:t>• Unit III: </a:t>
+              <a:t>• Unit IV: </a:t>
             </a:r>
             <a:r>
               <a:rPr sz="850">
@@ -3502,7 +3502,7 @@
                 </a:solidFill>
                 <a:latin typeface="Arial"/>
               </a:rPr>
-              <a:t>Abstract Classes (Question &amp; User)</a:t>
+              <a:t>Types of Errors &amp; Parameter Boundary Checks</a:t>
             </a:r>
           </a:p>
           <a:p>
@@ -3518,7 +3518,7 @@
                 </a:solidFill>
                 <a:latin typeface="Arial"/>
               </a:rPr>
-              <a:t>• Unit IV: </a:t>
+              <a:t>• Implementation: </a:t>
             </a:r>
             <a:r>
               <a:rPr sz="850">
@@ -3527,7 +3527,7 @@
                 </a:solidFill>
                 <a:latin typeface="Arial"/>
               </a:rPr>
-              <a:t>Types of Error &amp; Constructor Guards</a:t>
+              <a:t>Base class hierarchies &amp; abstract signatures</a:t>
             </a:r>
           </a:p>
           <a:p>
@@ -3552,7 +3552,7 @@
                 </a:solidFill>
                 <a:latin typeface="Arial"/>
               </a:rPr>
-              <a:t>IS-A Encapsulation &amp; Abstract Methods</a:t>
+              <a:t>Why use abstract class? vs Interface</a:t>
             </a:r>
           </a:p>
         </p:txBody>
@@ -3610,7 +3610,7 @@
               </a:defRPr>
             </a:pPr>
             <a:r>
-              <a:t>CORE DEVELOPER</a:t>
+              <a:t>POLYMORPHISM SPECIALIST</a:t>
             </a:r>
           </a:p>
           <a:p>
@@ -3655,7 +3655,7 @@
                 </a:solidFill>
                 <a:latin typeface="Arial"/>
               </a:rPr>
-              <a:t>• Role: </a:t>
+              <a:t>• Unit III: </a:t>
             </a:r>
             <a:r>
               <a:rPr sz="850">
@@ -3664,7 +3664,7 @@
                 </a:solidFill>
                 <a:latin typeface="Arial"/>
               </a:rPr>
-              <a:t>Polymorphic Questions Lead</a:t>
+              <a:t>Polymorphism &amp; Dynamic Dispatch (vtable)</a:t>
             </a:r>
           </a:p>
           <a:p>
@@ -3680,7 +3680,7 @@
                 </a:solidFill>
                 <a:latin typeface="Arial"/>
               </a:rPr>
-              <a:t>• Unit III: </a:t>
+              <a:t>• Unit IV: </a:t>
             </a:r>
             <a:r>
               <a:rPr sz="850">
@@ -3689,7 +3689,7 @@
                 </a:solidFill>
                 <a:latin typeface="Arial"/>
               </a:rPr>
-              <a:t>Overriding &amp; Dynamic Binding (vtable)</a:t>
+              <a:t>Checked vs Unchecked Exceptions</a:t>
             </a:r>
           </a:p>
           <a:p>
@@ -3705,7 +3705,7 @@
                 </a:solidFill>
                 <a:latin typeface="Arial"/>
               </a:rPr>
-              <a:t>• Unit IV: </a:t>
+              <a:t>• Implementation: </a:t>
             </a:r>
             <a:r>
               <a:rPr sz="850">
@@ -3714,7 +3714,7 @@
                 </a:solidFill>
                 <a:latin typeface="Arial"/>
               </a:rPr>
-              <a:t>Exception Interception (InvalidOption)</a:t>
+              <a:t>MCQ, True/False, Numeric &amp; checkAnswer()</a:t>
             </a:r>
           </a:p>
           <a:p>
@@ -3739,7 +3739,7 @@
                 </a:solidFill>
                 <a:latin typeface="Arial"/>
               </a:rPr>
-              <a:t>MCQ/TF/Num Dispatch &amp; Overloading</a:t>
+              <a:t>Dynamic method dispatch resolution via vtable</a:t>
             </a:r>
           </a:p>
         </p:txBody>
@@ -3797,7 +3797,7 @@
               </a:defRPr>
             </a:pPr>
             <a:r>
-              <a:t>STRATEGY ENGINEER</a:t>
+              <a:t>STRATEGY PATTERN LEAD</a:t>
             </a:r>
           </a:p>
           <a:p>
@@ -3842,7 +3842,7 @@
                 </a:solidFill>
                 <a:latin typeface="Arial"/>
               </a:rPr>
-              <a:t>• Role: </a:t>
+              <a:t>• Unit III: </a:t>
             </a:r>
             <a:r>
               <a:rPr sz="850">
@@ -3851,7 +3851,7 @@
                 </a:solidFill>
                 <a:latin typeface="Arial"/>
               </a:rPr>
-              <a:t>Service &amp; Design Pattern Lead</a:t>
+              <a:t>Interfaces &amp; Pluggable Strategy Pattern</a:t>
             </a:r>
           </a:p>
           <a:p>
@@ -3867,7 +3867,7 @@
                 </a:solidFill>
                 <a:latin typeface="Arial"/>
               </a:rPr>
-              <a:t>• Unit III: </a:t>
+              <a:t>• Unit IV: </a:t>
             </a:r>
             <a:r>
               <a:rPr sz="850">
@@ -3876,7 +3876,7 @@
                 </a:solidFill>
                 <a:latin typeface="Arial"/>
               </a:rPr>
-              <a:t>Interfaces &amp; Strategy Pattern (Grading)</a:t>
+              <a:t>try, catch, finally, throw, throws</a:t>
             </a:r>
           </a:p>
           <a:p>
@@ -3892,7 +3892,7 @@
                 </a:solidFill>
                 <a:latin typeface="Arial"/>
               </a:rPr>
-              <a:t>• Unit IV: </a:t>
+              <a:t>• Implementation: </a:t>
             </a:r>
             <a:r>
               <a:rPr sz="850">
@@ -3901,7 +3901,7 @@
                 </a:solidFill>
                 <a:latin typeface="Arial"/>
               </a:rPr>
-              <a:t>Exception Propagation &amp; 'throws' Signatures</a:t>
+              <a:t>QuizOperations &amp; Standard vs Negative grading</a:t>
             </a:r>
           </a:p>
           <a:p>
@@ -3926,7 +3926,7 @@
                 </a:solidFill>
                 <a:latin typeface="Arial"/>
               </a:rPr>
-              <a:t>QuizEvaluator Decoupling &amp; Open/Closed</a:t>
+              <a:t>QuizEvaluator design &amp; Open/Closed Principle</a:t>
             </a:r>
           </a:p>
         </p:txBody>
@@ -3984,7 +3984,7 @@
               </a:defRPr>
             </a:pPr>
             <a:r>
-              <a:t>QA &amp; TESTING</a:t>
+              <a:t>QA &amp; EXCEPTION ARCHITECT</a:t>
             </a:r>
           </a:p>
           <a:p>
@@ -4029,7 +4029,7 @@
                 </a:solidFill>
                 <a:latin typeface="Arial"/>
               </a:rPr>
-              <a:t>• Role: </a:t>
+              <a:t>• Unit III: </a:t>
             </a:r>
             <a:r>
               <a:rPr sz="850">
@@ -4038,7 +4038,7 @@
                 </a:solidFill>
                 <a:latin typeface="Arial"/>
               </a:rPr>
-              <a:t>Quality Assurance &amp; Exceptions Lead</a:t>
+              <a:t>Interface Implementation &amp; Collections</a:t>
             </a:r>
           </a:p>
           <a:p>
@@ -4054,7 +4054,7 @@
                 </a:solidFill>
                 <a:latin typeface="Arial"/>
               </a:rPr>
-              <a:t>• Unit III: </a:t>
+              <a:t>• Unit IV: </a:t>
             </a:r>
             <a:r>
               <a:rPr sz="850">
@@ -4063,7 +4063,7 @@
                 </a:solidFill>
                 <a:latin typeface="Arial"/>
               </a:rPr>
-              <a:t>QuizManager Operations Implementation</a:t>
+              <a:t>5-Tier Custom Checked Exceptions</a:t>
             </a:r>
           </a:p>
           <a:p>
@@ -4079,7 +4079,7 @@
                 </a:solidFill>
                 <a:latin typeface="Arial"/>
               </a:rPr>
-              <a:t>• Unit IV: </a:t>
+              <a:t>• Implementation: </a:t>
             </a:r>
             <a:r>
               <a:rPr sz="850">
@@ -4088,7 +4088,7 @@
                 </a:solidFill>
                 <a:latin typeface="Arial"/>
               </a:rPr>
-              <a:t>5-Tier Checked Exceptions &amp; try-finally</a:t>
+              <a:t>QuizException tree, InputValidator &amp; Tests</a:t>
             </a:r>
           </a:p>
           <a:p>
@@ -4113,7 +4113,7 @@
                 </a:solidFill>
                 <a:latin typeface="Arial"/>
               </a:rPr>
-              <a:t>Domain Exception Tree &amp; Crash Prevention</a:t>
+              <a:t>Handling custom exceptions &amp; try-catch-finally</a:t>
             </a:r>
           </a:p>
         </p:txBody>
@@ -4309,7 +4309,7 @@
       </p:sp>
       <p:pic>
         <p:nvPicPr>
-          <p:cNvPr id="5" name="Picture 4" descr="ait_badge.jpg"/>
+          <p:cNvPr id="5" name="Picture 4" descr="ait_official_badge.png"/>
           <p:cNvPicPr>
             <a:picLocks noChangeAspect="1"/>
           </p:cNvPicPr>
@@ -5080,7 +5080,7 @@
       </p:sp>
       <p:pic>
         <p:nvPicPr>
-          <p:cNvPr id="5" name="Picture 4" descr="ait_badge.jpg"/>
+          <p:cNvPr id="5" name="Picture 4" descr="ait_official_badge.png"/>
           <p:cNvPicPr>
             <a:picLocks noChangeAspect="1"/>
           </p:cNvPicPr>
@@ -6067,7 +6067,7 @@
       </p:sp>
       <p:pic>
         <p:nvPicPr>
-          <p:cNvPr id="5" name="Picture 4" descr="ait_badge.jpg"/>
+          <p:cNvPr id="5" name="Picture 4" descr="ait_official_badge.png"/>
           <p:cNvPicPr>
             <a:picLocks noChangeAspect="1"/>
           </p:cNvPicPr>

</xml_diff>